<commit_message>
Asia Disrupted World Order
</commit_message>
<xml_diff>
--- a/Storage/2026.09-Asia-in-a-Disrupted-World-Order-Danny.Quah-crafted-CP.pptx
+++ b/Storage/2026.09-Asia-in-a-Disrupted-World-Order-Danny.Quah-crafted-CP.pptx
@@ -3485,7 +3485,7 @@
               </a:defRPr>
             </a:pPr>
             <a:r>
-              <a:rPr sz="2325" b="1" i="0">
+              <a:rPr sz="2800" b="1" i="0" dirty="0">
                 <a:solidFill>
                   <a:srgbClr val="263B3F"/>
                 </a:solidFill>
@@ -3703,7 +3703,7 @@
         <p:spPr>
           <a:xfrm>
             <a:off x="904875" y="2286000"/>
-            <a:ext cx="4619625" cy="1524000"/>
+            <a:ext cx="4619625" cy="1796902"/>
           </a:xfrm>
           <a:prstGeom prst="rect">
             <a:avLst/>
@@ -3715,7 +3715,7 @@
         </p:spPr>
         <p:txBody>
           <a:bodyPr anchor="ctr">
-            <a:normAutofit/>
+            <a:noAutofit/>
           </a:bodyPr>
           <a:lstStyle/>
           <a:p>
@@ -3730,7 +3730,7 @@
               </a:defRPr>
             </a:pPr>
             <a:r>
-              <a:rPr sz="1800" b="1" i="0">
+              <a:rPr sz="2400" b="1" i="0" dirty="0">
                 <a:solidFill>
                   <a:srgbClr val="263B3F"/>
                 </a:solidFill>
@@ -3911,7 +3911,7 @@
         <p:spPr>
           <a:xfrm>
             <a:off x="6619875" y="2286000"/>
-            <a:ext cx="4619625" cy="1619250"/>
+            <a:ext cx="4619625" cy="1796902"/>
           </a:xfrm>
           <a:prstGeom prst="rect">
             <a:avLst/>
@@ -3938,7 +3938,7 @@
               </a:defRPr>
             </a:pPr>
             <a:r>
-              <a:rPr sz="1800" b="1" i="0">
+              <a:rPr sz="2400" b="1" i="0" dirty="0">
                 <a:solidFill>
                   <a:srgbClr val="FFFFFF"/>
                 </a:solidFill>
@@ -4090,7 +4090,7 @@
               </a:defRPr>
             </a:pPr>
             <a:r>
-              <a:rPr sz="2325" b="1" i="0">
+              <a:rPr sz="2800" b="1" i="0" dirty="0">
                 <a:solidFill>
                   <a:srgbClr val="263B3F"/>
                 </a:solidFill>
@@ -4335,7 +4335,7 @@
               </a:defRPr>
             </a:pPr>
             <a:r>
-              <a:rPr sz="1725" b="0" i="0">
+              <a:rPr sz="2400" b="0" i="0" dirty="0">
                 <a:solidFill>
                   <a:srgbClr val="263B3F"/>
                 </a:solidFill>
@@ -4471,7 +4471,7 @@
         </p:spPr>
         <p:txBody>
           <a:bodyPr anchor="ctr">
-            <a:normAutofit/>
+            <a:noAutofit/>
           </a:bodyPr>
           <a:lstStyle/>
           <a:p>
@@ -4486,15 +4486,48 @@
               </a:defRPr>
             </a:pPr>
             <a:r>
-              <a:rPr sz="1725" b="0" i="0">
-                <a:solidFill>
-                  <a:srgbClr val="263B3F"/>
-                </a:solidFill>
-                <a:latin typeface="Calibri"/>
-                <a:ea typeface="Calibri"/>
-                <a:cs typeface="Calibri"/>
-              </a:rPr>
-              <a:t>Lipset, Fukuyama and Clinton expected prosperity and integration to encourage political convergence. Markets delivered wealth more reliably than they delivered convergence.</a:t>
+              <a:rPr sz="2400" b="0" i="0" dirty="0" err="1">
+                <a:solidFill>
+                  <a:srgbClr val="263B3F"/>
+                </a:solidFill>
+                <a:latin typeface="Calibri"/>
+                <a:ea typeface="Calibri"/>
+                <a:cs typeface="Calibri"/>
+              </a:rPr>
+              <a:t>Lipset</a:t>
+            </a:r>
+            <a:r>
+              <a:rPr sz="2400" b="0" i="0" dirty="0">
+                <a:solidFill>
+                  <a:srgbClr val="263B3F"/>
+                </a:solidFill>
+                <a:latin typeface="Calibri"/>
+                <a:ea typeface="Calibri"/>
+                <a:cs typeface="Calibri"/>
+              </a:rPr>
+              <a:t>, Fukuyama</a:t>
+            </a:r>
+            <a:r>
+              <a:rPr lang="en-US" sz="2400" b="0" i="0" dirty="0">
+                <a:solidFill>
+                  <a:srgbClr val="263B3F"/>
+                </a:solidFill>
+                <a:latin typeface="Calibri"/>
+                <a:ea typeface="Calibri"/>
+                <a:cs typeface="Calibri"/>
+              </a:rPr>
+              <a:t>,</a:t>
+            </a:r>
+            <a:r>
+              <a:rPr sz="2400" b="0" i="0" dirty="0">
+                <a:solidFill>
+                  <a:srgbClr val="263B3F"/>
+                </a:solidFill>
+                <a:latin typeface="Calibri"/>
+                <a:ea typeface="Calibri"/>
+                <a:cs typeface="Calibri"/>
+              </a:rPr>
+              <a:t> and Clinton expected prosperity and integration to encourage political convergence. Markets delivered wealth more reliably than they delivered convergence.</a:t>
             </a:r>
           </a:p>
         </p:txBody>
@@ -4581,7 +4614,7 @@
               </a:defRPr>
             </a:pPr>
             <a:r>
-              <a:rPr sz="2325" b="1" i="0">
+              <a:rPr sz="2800" b="1" i="0" dirty="0">
                 <a:solidFill>
                   <a:srgbClr val="263B3F"/>
                 </a:solidFill>
@@ -4885,7 +4918,7 @@
               </a:defRPr>
             </a:pPr>
             <a:r>
-              <a:rPr sz="1350" b="0" i="0">
+              <a:rPr sz="2400" b="0" i="0" dirty="0">
                 <a:solidFill>
                   <a:srgbClr val="263B3F"/>
                 </a:solidFill>
@@ -5080,7 +5113,7 @@
         </p:spPr>
         <p:txBody>
           <a:bodyPr anchor="ctr">
-            <a:normAutofit/>
+            <a:noAutofit/>
           </a:bodyPr>
           <a:lstStyle/>
           <a:p>
@@ -5095,7 +5128,7 @@
               </a:defRPr>
             </a:pPr>
             <a:r>
-              <a:rPr sz="1350" b="0" i="0">
+              <a:rPr sz="2400" b="0" i="0" dirty="0">
                 <a:solidFill>
                   <a:srgbClr val="263B3F"/>
                 </a:solidFill>
@@ -5305,7 +5338,7 @@
               </a:defRPr>
             </a:pPr>
             <a:r>
-              <a:rPr sz="1350" b="0" i="0">
+              <a:rPr sz="2400" b="0" i="0" dirty="0">
                 <a:solidFill>
                   <a:srgbClr val="263B3F"/>
                 </a:solidFill>
@@ -5335,7 +5368,7 @@
         <p:spPr>
           <a:xfrm>
             <a:off x="495300" y="5476875"/>
-            <a:ext cx="11201400" cy="457200"/>
+            <a:ext cx="11201400" cy="902660"/>
           </a:xfrm>
           <a:prstGeom prst="rect">
             <a:avLst/>
@@ -5362,7 +5395,7 @@
               </a:defRPr>
             </a:pPr>
             <a:r>
-              <a:rPr sz="1800" b="1" i="0">
+              <a:rPr sz="2400" b="1" i="0" dirty="0">
                 <a:solidFill>
                   <a:srgbClr val="F28C18"/>
                 </a:solidFill>
@@ -5457,7 +5490,7 @@
               </a:defRPr>
             </a:pPr>
             <a:r>
-              <a:rPr sz="2325" b="1" i="0">
+              <a:rPr sz="2800" b="1" i="0" dirty="0">
                 <a:solidFill>
                   <a:srgbClr val="263B3F"/>
                 </a:solidFill>
@@ -5761,7 +5794,7 @@
               </a:defRPr>
             </a:pPr>
             <a:r>
-              <a:rPr sz="1350" b="0" i="0">
+              <a:rPr sz="2400" b="0" i="0" dirty="0">
                 <a:solidFill>
                   <a:srgbClr val="263B3F"/>
                 </a:solidFill>
@@ -5971,15 +6004,37 @@
               </a:defRPr>
             </a:pPr>
             <a:r>
-              <a:rPr sz="1350" b="0" i="0">
-                <a:solidFill>
-                  <a:srgbClr val="263B3F"/>
-                </a:solidFill>
-                <a:latin typeface="Calibri"/>
-                <a:ea typeface="Calibri"/>
-                <a:cs typeface="Calibri"/>
-              </a:rPr>
-              <a:t>Access to the largest rich market became conditional on purchases, investment and political concessions.</a:t>
+              <a:rPr sz="2400" b="0" i="0" dirty="0">
+                <a:solidFill>
+                  <a:srgbClr val="263B3F"/>
+                </a:solidFill>
+                <a:latin typeface="Calibri"/>
+                <a:ea typeface="Calibri"/>
+                <a:cs typeface="Calibri"/>
+              </a:rPr>
+              <a:t>Access to the largest rich market became conditional on purchases, investment</a:t>
+            </a:r>
+            <a:r>
+              <a:rPr lang="en-US" sz="2400" b="0" i="0" dirty="0">
+                <a:solidFill>
+                  <a:srgbClr val="263B3F"/>
+                </a:solidFill>
+                <a:latin typeface="Calibri"/>
+                <a:ea typeface="Calibri"/>
+                <a:cs typeface="Calibri"/>
+              </a:rPr>
+              <a:t>,</a:t>
+            </a:r>
+            <a:r>
+              <a:rPr sz="2400" b="0" i="0" dirty="0">
+                <a:solidFill>
+                  <a:srgbClr val="263B3F"/>
+                </a:solidFill>
+                <a:latin typeface="Calibri"/>
+                <a:ea typeface="Calibri"/>
+                <a:cs typeface="Calibri"/>
+              </a:rPr>
+              <a:t> and political concessions.</a:t>
             </a:r>
           </a:p>
         </p:txBody>
@@ -6181,7 +6236,7 @@
               </a:defRPr>
             </a:pPr>
             <a:r>
-              <a:rPr sz="1350" b="0" i="0">
+              <a:rPr sz="2400" b="0" i="0" dirty="0">
                 <a:solidFill>
                   <a:srgbClr val="263B3F"/>
                 </a:solidFill>
@@ -6276,7 +6331,7 @@
               </a:defRPr>
             </a:pPr>
             <a:r>
-              <a:rPr sz="2325" b="1" i="0">
+              <a:rPr sz="2800" b="1" i="0" dirty="0">
                 <a:solidFill>
                   <a:srgbClr val="263B3F"/>
                 </a:solidFill>
@@ -6778,8 +6833,8 @@
         </p:nvSpPr>
         <p:spPr>
           <a:xfrm>
-            <a:off x="762000" y="4953000"/>
-            <a:ext cx="10668000" cy="666750"/>
+            <a:off x="762000" y="4952999"/>
+            <a:ext cx="10668000" cy="1320209"/>
           </a:xfrm>
           <a:prstGeom prst="rect">
             <a:avLst/>
@@ -6806,7 +6861,7 @@
               </a:defRPr>
             </a:pPr>
             <a:r>
-              <a:rPr sz="1875" b="1" i="0">
+              <a:rPr sz="2400" b="1" i="0" dirty="0">
                 <a:solidFill>
                   <a:srgbClr val="263B3F"/>
                 </a:solidFill>
@@ -6901,7 +6956,7 @@
               </a:defRPr>
             </a:pPr>
             <a:r>
-              <a:rPr sz="2325" b="1" i="0">
+              <a:rPr sz="2800" b="1" i="0" dirty="0">
                 <a:solidFill>
                   <a:srgbClr val="263B3F"/>
                 </a:solidFill>
@@ -8764,8 +8819,8 @@
         </p:nvSpPr>
         <p:spPr>
           <a:xfrm>
-            <a:off x="666750" y="5000625"/>
-            <a:ext cx="10668000" cy="476250"/>
+            <a:off x="666750" y="5000624"/>
+            <a:ext cx="10668000" cy="1240687"/>
           </a:xfrm>
           <a:prstGeom prst="rect">
             <a:avLst/>
@@ -8792,7 +8847,7 @@
               </a:defRPr>
             </a:pPr>
             <a:r>
-              <a:rPr sz="1875" b="1" i="0">
+              <a:rPr sz="2400" b="1" i="0" dirty="0">
                 <a:solidFill>
                   <a:srgbClr val="F28C18"/>
                 </a:solidFill>
@@ -8887,15 +8942,15 @@
               </a:defRPr>
             </a:pPr>
             <a:r>
-              <a:rPr sz="2325" b="1" i="0">
-                <a:solidFill>
-                  <a:srgbClr val="263B3F"/>
-                </a:solidFill>
-                <a:latin typeface="Calibri"/>
-                <a:ea typeface="Calibri"/>
-                <a:cs typeface="Calibri"/>
-              </a:rPr>
-              <a:t>The geoeconomic turn survived its legal setback</a:t>
+              <a:rPr sz="2800" b="1" i="0" dirty="0">
+                <a:solidFill>
+                  <a:srgbClr val="263B3F"/>
+                </a:solidFill>
+                <a:latin typeface="Calibri"/>
+                <a:ea typeface="Calibri"/>
+                <a:cs typeface="Calibri"/>
+              </a:rPr>
+              <a:t>The geoeconomic turn survived legal setback</a:t>
             </a:r>
           </a:p>
         </p:txBody>
@@ -9104,8 +9159,8 @@
         </p:nvSpPr>
         <p:spPr>
           <a:xfrm>
-            <a:off x="904875" y="2476500"/>
-            <a:ext cx="4476750" cy="1619250"/>
+            <a:off x="904875" y="2476499"/>
+            <a:ext cx="4476750" cy="1999807"/>
           </a:xfrm>
           <a:prstGeom prst="rect">
             <a:avLst/>
@@ -9132,7 +9187,7 @@
               </a:defRPr>
             </a:pPr>
             <a:r>
-              <a:rPr sz="1875" b="1" i="0">
+              <a:rPr sz="2400" b="1" i="0" dirty="0">
                 <a:solidFill>
                   <a:srgbClr val="FFFFFF"/>
                 </a:solidFill>
@@ -9140,7 +9195,29 @@
                 <a:ea typeface="Calibri"/>
                 <a:cs typeface="Calibri"/>
               </a:rPr>
-              <a:t>The Court held that IEEPA did not authorise the Liberation Day tariffs. Importers became entitled to refunds.</a:t>
+              <a:t>The Court held that IEEPA did not </a:t>
+            </a:r>
+            <a:r>
+              <a:rPr sz="2400" b="1" i="0" dirty="0" err="1">
+                <a:solidFill>
+                  <a:srgbClr val="FFFFFF"/>
+                </a:solidFill>
+                <a:latin typeface="Calibri"/>
+                <a:ea typeface="Calibri"/>
+                <a:cs typeface="Calibri"/>
+              </a:rPr>
+              <a:t>authorise</a:t>
+            </a:r>
+            <a:r>
+              <a:rPr sz="2400" b="1" i="0" dirty="0">
+                <a:solidFill>
+                  <a:srgbClr val="FFFFFF"/>
+                </a:solidFill>
+                <a:latin typeface="Calibri"/>
+                <a:ea typeface="Calibri"/>
+                <a:cs typeface="Calibri"/>
+              </a:rPr>
+              <a:t> the Liberation Day tariffs. Importers became entitled to refunds.</a:t>
             </a:r>
           </a:p>
         </p:txBody>
@@ -9256,7 +9333,7 @@
         <p:spPr>
           <a:xfrm>
             <a:off x="6429375" y="2428875"/>
-            <a:ext cx="4762500" cy="1619250"/>
+            <a:ext cx="4762500" cy="2143126"/>
           </a:xfrm>
           <a:prstGeom prst="rect">
             <a:avLst/>
@@ -9283,7 +9360,7 @@
               </a:defRPr>
             </a:pPr>
             <a:r>
-              <a:rPr sz="1650" b="0" i="0">
+              <a:rPr sz="2400" b="0" i="0" dirty="0">
                 <a:solidFill>
                   <a:srgbClr val="263B3F"/>
                 </a:solidFill>
@@ -9306,15 +9383,37 @@
               </a:defRPr>
             </a:pPr>
             <a:r>
-              <a:rPr sz="1650" b="0" i="0">
-                <a:solidFill>
-                  <a:srgbClr val="263B3F"/>
-                </a:solidFill>
-                <a:latin typeface="Calibri"/>
-                <a:ea typeface="Calibri"/>
-                <a:cs typeface="Calibri"/>
-              </a:rPr>
-              <a:t>• Section 301: targeted tariffs on forced-labour and overcapacity grounds</a:t>
+              <a:rPr sz="2400" b="0" i="0" dirty="0">
+                <a:solidFill>
+                  <a:srgbClr val="263B3F"/>
+                </a:solidFill>
+                <a:latin typeface="Calibri"/>
+                <a:ea typeface="Calibri"/>
+                <a:cs typeface="Calibri"/>
+              </a:rPr>
+              <a:t>• Section 301: targeted tariffs on forced-</a:t>
+            </a:r>
+            <a:r>
+              <a:rPr sz="2400" b="0" i="0" dirty="0" err="1">
+                <a:solidFill>
+                  <a:srgbClr val="263B3F"/>
+                </a:solidFill>
+                <a:latin typeface="Calibri"/>
+                <a:ea typeface="Calibri"/>
+                <a:cs typeface="Calibri"/>
+              </a:rPr>
+              <a:t>labour</a:t>
+            </a:r>
+            <a:r>
+              <a:rPr sz="2400" b="0" i="0" dirty="0">
+                <a:solidFill>
+                  <a:srgbClr val="263B3F"/>
+                </a:solidFill>
+                <a:latin typeface="Calibri"/>
+                <a:ea typeface="Calibri"/>
+                <a:cs typeface="Calibri"/>
+              </a:rPr>
+              <a:t> and overcapacity grounds</a:t>
             </a:r>
           </a:p>
         </p:txBody>
@@ -9336,7 +9435,7 @@
         <p:spPr>
           <a:xfrm>
             <a:off x="666750" y="5238750"/>
-            <a:ext cx="10858500" cy="523875"/>
+            <a:ext cx="10858500" cy="981297"/>
           </a:xfrm>
           <a:prstGeom prst="rect">
             <a:avLst/>
@@ -9363,15 +9462,26 @@
               </a:defRPr>
             </a:pPr>
             <a:r>
-              <a:rPr sz="1875" b="1" i="0">
-                <a:solidFill>
-                  <a:srgbClr val="263B3F"/>
-                </a:solidFill>
-                <a:latin typeface="Calibri"/>
-                <a:ea typeface="Calibri"/>
-                <a:cs typeface="Calibri"/>
-              </a:rPr>
-              <a:t>A court ruling removed one legal route, not the geoeconomic policy turn</a:t>
+              <a:rPr lang="en-US" sz="2400" b="1" i="0" dirty="0">
+                <a:solidFill>
+                  <a:srgbClr val="263B3F"/>
+                </a:solidFill>
+                <a:latin typeface="Calibri"/>
+                <a:ea typeface="Calibri"/>
+                <a:cs typeface="Calibri"/>
+              </a:rPr>
+              <a:t>C</a:t>
+            </a:r>
+            <a:r>
+              <a:rPr sz="2400" b="1" i="0" dirty="0">
+                <a:solidFill>
+                  <a:srgbClr val="263B3F"/>
+                </a:solidFill>
+                <a:latin typeface="Calibri"/>
+                <a:ea typeface="Calibri"/>
+                <a:cs typeface="Calibri"/>
+              </a:rPr>
+              <a:t>ourt ruling removed one legal route, not the geoeconomic policy turn</a:t>
             </a:r>
           </a:p>
         </p:txBody>
@@ -9458,7 +9568,7 @@
               </a:defRPr>
             </a:pPr>
             <a:r>
-              <a:rPr sz="2325" b="1" i="0">
+              <a:rPr sz="2800" b="1" i="0" dirty="0">
                 <a:solidFill>
                   <a:srgbClr val="263B3F"/>
                 </a:solidFill>
@@ -9515,7 +9625,7 @@
               </a:defRPr>
             </a:pPr>
             <a:r>
-              <a:rPr sz="1200" b="0" i="1">
+              <a:rPr sz="1200" b="0" i="1" dirty="0">
                 <a:solidFill>
                   <a:srgbClr val="657275"/>
                 </a:solidFill>
@@ -9523,7 +9633,29 @@
                 <a:ea typeface="Calibri"/>
                 <a:cs typeface="Calibri"/>
               </a:rPr>
-              <a:t>China and the US altered relationships. Rules erosion altered how all relationships are managed.</a:t>
+              <a:t>China and the US altered relationships. Rules erosion altered </a:t>
+            </a:r>
+            <a:r>
+              <a:rPr lang="en-US" sz="1200" i="1" dirty="0">
+                <a:solidFill>
+                  <a:srgbClr val="657275"/>
+                </a:solidFill>
+                <a:latin typeface="Calibri"/>
+                <a:ea typeface="Calibri"/>
+                <a:cs typeface="Calibri"/>
+              </a:rPr>
+              <a:t>management of</a:t>
+            </a:r>
+            <a:r>
+              <a:rPr sz="1200" b="0" i="1" dirty="0">
+                <a:solidFill>
+                  <a:srgbClr val="657275"/>
+                </a:solidFill>
+                <a:latin typeface="Calibri"/>
+                <a:ea typeface="Calibri"/>
+                <a:cs typeface="Calibri"/>
+              </a:rPr>
+              <a:t> all relationships.</a:t>
             </a:r>
           </a:p>
         </p:txBody>
@@ -9984,8 +10116,8 @@
         </p:nvSpPr>
         <p:spPr>
           <a:xfrm>
-            <a:off x="714375" y="3714750"/>
-            <a:ext cx="10763250" cy="1238250"/>
+            <a:off x="714375" y="4000500"/>
+            <a:ext cx="10763250" cy="1704974"/>
           </a:xfrm>
           <a:prstGeom prst="rect">
             <a:avLst/>
@@ -10021,8 +10153,8 @@
         </p:nvSpPr>
         <p:spPr>
           <a:xfrm>
-            <a:off x="1047750" y="4000500"/>
-            <a:ext cx="10096500" cy="666750"/>
+            <a:off x="1047750" y="4403213"/>
+            <a:ext cx="10096500" cy="952500"/>
           </a:xfrm>
           <a:prstGeom prst="rect">
             <a:avLst/>
@@ -10049,16 +10181,57 @@
               </a:defRPr>
             </a:pPr>
             <a:r>
-              <a:rPr sz="2025" b="1" i="0">
-                <a:solidFill>
-                  <a:srgbClr val="263B3F"/>
-                </a:solidFill>
-                <a:latin typeface="Calibri"/>
-                <a:ea typeface="Calibri"/>
-                <a:cs typeface="Calibri"/>
-              </a:rPr>
-              <a:t>When exceptions multiply and dispute settlement weakens, small states lose the institutional leverage that made openness tolerable</a:t>
-            </a:r>
+              <a:rPr sz="2400" b="1" i="0" dirty="0">
+                <a:solidFill>
+                  <a:srgbClr val="263B3F"/>
+                </a:solidFill>
+                <a:latin typeface="Calibri"/>
+                <a:ea typeface="Calibri"/>
+                <a:cs typeface="Calibri"/>
+              </a:rPr>
+              <a:t>When exceptions multiply and dispute settlement weakens, small states lose the institutional leverage that made </a:t>
+            </a:r>
+            <a:r>
+              <a:rPr lang="en-US" sz="2400" b="1" i="0" dirty="0">
+                <a:solidFill>
+                  <a:srgbClr val="263B3F"/>
+                </a:solidFill>
+                <a:latin typeface="Calibri"/>
+                <a:ea typeface="Calibri"/>
+                <a:cs typeface="Calibri"/>
+              </a:rPr>
+              <a:t>engagement</a:t>
+            </a:r>
+            <a:r>
+              <a:rPr sz="2400" b="1" i="0" dirty="0">
+                <a:solidFill>
+                  <a:srgbClr val="263B3F"/>
+                </a:solidFill>
+                <a:latin typeface="Calibri"/>
+                <a:ea typeface="Calibri"/>
+                <a:cs typeface="Calibri"/>
+              </a:rPr>
+              <a:t> </a:t>
+            </a:r>
+            <a:r>
+              <a:rPr lang="en-US" sz="2400" b="1" i="0" dirty="0">
+                <a:solidFill>
+                  <a:srgbClr val="263B3F"/>
+                </a:solidFill>
+                <a:latin typeface="Calibri"/>
+                <a:ea typeface="Calibri"/>
+                <a:cs typeface="Calibri"/>
+              </a:rPr>
+              <a:t>beneficial</a:t>
+            </a:r>
+            <a:endParaRPr sz="2400" b="1" i="0" dirty="0">
+              <a:solidFill>
+                <a:srgbClr val="263B3F"/>
+              </a:solidFill>
+              <a:latin typeface="Calibri"/>
+              <a:ea typeface="Calibri"/>
+              <a:cs typeface="Calibri"/>
+            </a:endParaRPr>
           </a:p>
         </p:txBody>
       </p:sp>
@@ -10716,15 +10889,37 @@
               </a:defRPr>
             </a:pPr>
             <a:r>
-              <a:rPr sz="1350" b="0" i="0">
-                <a:solidFill>
-                  <a:srgbClr val="263B3F"/>
-                </a:solidFill>
-                <a:latin typeface="Calibri"/>
-                <a:ea typeface="Calibri"/>
-                <a:cs typeface="Calibri"/>
-              </a:rPr>
-              <a:t>Capital, demand and infrastructure can support diversification and development.</a:t>
+              <a:rPr sz="2400" b="0" i="0" dirty="0">
+                <a:solidFill>
+                  <a:srgbClr val="263B3F"/>
+                </a:solidFill>
+                <a:latin typeface="Calibri"/>
+                <a:ea typeface="Calibri"/>
+                <a:cs typeface="Calibri"/>
+              </a:rPr>
+              <a:t>Capital, demand</a:t>
+            </a:r>
+            <a:r>
+              <a:rPr lang="en-US" sz="2400" b="0" i="0" dirty="0">
+                <a:solidFill>
+                  <a:srgbClr val="263B3F"/>
+                </a:solidFill>
+                <a:latin typeface="Calibri"/>
+                <a:ea typeface="Calibri"/>
+                <a:cs typeface="Calibri"/>
+              </a:rPr>
+              <a:t>,</a:t>
+            </a:r>
+            <a:r>
+              <a:rPr sz="2400" b="0" i="0" dirty="0">
+                <a:solidFill>
+                  <a:srgbClr val="263B3F"/>
+                </a:solidFill>
+                <a:latin typeface="Calibri"/>
+                <a:ea typeface="Calibri"/>
+                <a:cs typeface="Calibri"/>
+              </a:rPr>
+              <a:t> and infrastructure can support diversification and development.</a:t>
             </a:r>
           </a:p>
         </p:txBody>
@@ -10926,15 +11121,37 @@
               </a:defRPr>
             </a:pPr>
             <a:r>
-              <a:rPr sz="1350" b="0" i="0">
-                <a:solidFill>
-                  <a:srgbClr val="263B3F"/>
-                </a:solidFill>
-                <a:latin typeface="Calibri"/>
-                <a:ea typeface="Calibri"/>
-                <a:cs typeface="Calibri"/>
-              </a:rPr>
-              <a:t>A narrow export base and concentrated investment can limit future room for manoeuvre.</a:t>
+              <a:rPr sz="2400" b="0" i="0" dirty="0">
+                <a:solidFill>
+                  <a:srgbClr val="263B3F"/>
+                </a:solidFill>
+                <a:latin typeface="Calibri"/>
+                <a:ea typeface="Calibri"/>
+                <a:cs typeface="Calibri"/>
+              </a:rPr>
+              <a:t>A narrow export base and concentrated investment can limit future room for </a:t>
+            </a:r>
+            <a:r>
+              <a:rPr sz="2400" b="0" i="0" dirty="0" err="1">
+                <a:solidFill>
+                  <a:srgbClr val="263B3F"/>
+                </a:solidFill>
+                <a:latin typeface="Calibri"/>
+                <a:ea typeface="Calibri"/>
+                <a:cs typeface="Calibri"/>
+              </a:rPr>
+              <a:t>manoeuvre</a:t>
+            </a:r>
+            <a:r>
+              <a:rPr sz="2400" b="0" i="0" dirty="0">
+                <a:solidFill>
+                  <a:srgbClr val="263B3F"/>
+                </a:solidFill>
+                <a:latin typeface="Calibri"/>
+                <a:ea typeface="Calibri"/>
+                <a:cs typeface="Calibri"/>
+              </a:rPr>
+              <a:t>.</a:t>
             </a:r>
           </a:p>
         </p:txBody>
@@ -11136,15 +11353,37 @@
               </a:defRPr>
             </a:pPr>
             <a:r>
-              <a:rPr sz="1350" b="0" i="0">
-                <a:solidFill>
-                  <a:srgbClr val="263B3F"/>
-                </a:solidFill>
-                <a:latin typeface="Calibri"/>
-                <a:ea typeface="Calibri"/>
-                <a:cs typeface="Calibri"/>
-              </a:rPr>
-              <a:t>Which assets, relationships or institutions allow Brunei to shape the bargain?</a:t>
+              <a:rPr sz="2400" b="0" i="0" dirty="0">
+                <a:solidFill>
+                  <a:srgbClr val="263B3F"/>
+                </a:solidFill>
+                <a:latin typeface="Calibri"/>
+                <a:ea typeface="Calibri"/>
+                <a:cs typeface="Calibri"/>
+              </a:rPr>
+              <a:t>Which assets, relationships</a:t>
+            </a:r>
+            <a:r>
+              <a:rPr lang="en-US" sz="2400" b="0" i="0" dirty="0">
+                <a:solidFill>
+                  <a:srgbClr val="263B3F"/>
+                </a:solidFill>
+                <a:latin typeface="Calibri"/>
+                <a:ea typeface="Calibri"/>
+                <a:cs typeface="Calibri"/>
+              </a:rPr>
+              <a:t>,</a:t>
+            </a:r>
+            <a:r>
+              <a:rPr sz="2400" b="0" i="0" dirty="0">
+                <a:solidFill>
+                  <a:srgbClr val="263B3F"/>
+                </a:solidFill>
+                <a:latin typeface="Calibri"/>
+                <a:ea typeface="Calibri"/>
+                <a:cs typeface="Calibri"/>
+              </a:rPr>
+              <a:t> or institutions allow Brunei to shape the bargain?</a:t>
             </a:r>
           </a:p>
         </p:txBody>
@@ -12062,7 +12301,7 @@
               </a:defRPr>
             </a:pPr>
             <a:r>
-              <a:rPr sz="1875" b="1" i="0">
+              <a:rPr sz="2400" b="1" i="0" dirty="0">
                 <a:solidFill>
                   <a:srgbClr val="263B3F"/>
                 </a:solidFill>
@@ -12198,7 +12437,7 @@
         </p:spPr>
         <p:txBody>
           <a:bodyPr anchor="ctr">
-            <a:normAutofit/>
+            <a:noAutofit/>
           </a:bodyPr>
           <a:lstStyle/>
           <a:p>
@@ -12213,7 +12452,7 @@
               </a:defRPr>
             </a:pPr>
             <a:r>
-              <a:rPr sz="1875" b="1" i="0">
+              <a:rPr sz="2400" b="1" i="0" dirty="0">
                 <a:solidFill>
                   <a:srgbClr val="263B3F"/>
                 </a:solidFill>
@@ -13195,7 +13434,7 @@
               </a:defRPr>
             </a:pPr>
             <a:r>
-              <a:rPr sz="1350" b="0" i="0">
+              <a:rPr sz="2400" b="0" i="0" dirty="0">
                 <a:solidFill>
                   <a:srgbClr val="263B3F"/>
                 </a:solidFill>
@@ -13405,7 +13644,7 @@
               </a:defRPr>
             </a:pPr>
             <a:r>
-              <a:rPr sz="1350" b="0" i="0">
+              <a:rPr sz="2400" b="0" i="0" dirty="0">
                 <a:solidFill>
                   <a:srgbClr val="263B3F"/>
                 </a:solidFill>
@@ -13615,7 +13854,7 @@
               </a:defRPr>
             </a:pPr>
             <a:r>
-              <a:rPr sz="1350" b="0" i="0">
+              <a:rPr sz="2400" b="0" i="0" dirty="0">
                 <a:solidFill>
                   <a:srgbClr val="263B3F"/>
                 </a:solidFill>
@@ -13657,7 +13896,7 @@
         </p:spPr>
         <p:txBody>
           <a:bodyPr anchor="ctr">
-            <a:normAutofit/>
+            <a:noAutofit/>
           </a:bodyPr>
           <a:lstStyle/>
           <a:p>
@@ -13672,7 +13911,7 @@
               </a:defRPr>
             </a:pPr>
             <a:r>
-              <a:rPr sz="1875" b="1" i="0">
+              <a:rPr sz="2400" b="1" i="0" dirty="0">
                 <a:solidFill>
                   <a:srgbClr val="F28C18"/>
                 </a:solidFill>
@@ -16220,7 +16459,7 @@
         </p:spPr>
         <p:txBody>
           <a:bodyPr anchor="ctr">
-            <a:normAutofit/>
+            <a:noAutofit/>
           </a:bodyPr>
           <a:lstStyle/>
           <a:p>
@@ -16235,7 +16474,7 @@
               </a:defRPr>
             </a:pPr>
             <a:r>
-              <a:rPr sz="1350" b="0" i="0">
+              <a:rPr sz="2400" b="0" i="0" dirty="0">
                 <a:solidFill>
                   <a:srgbClr val="263B3F"/>
                 </a:solidFill>
@@ -16247,7 +16486,7 @@
             </a:r>
           </a:p>
           <a:p>
-            <a:endParaRPr sz="1350" b="0" i="0">
+            <a:endParaRPr sz="2400" b="0" i="0" dirty="0">
               <a:solidFill>
                 <a:srgbClr val="263B3F"/>
               </a:solidFill>
@@ -16268,7 +16507,7 @@
               </a:defRPr>
             </a:pPr>
             <a:r>
-              <a:rPr sz="1350" b="0" i="0">
+              <a:rPr sz="2400" b="0" i="0" dirty="0">
                 <a:solidFill>
                   <a:srgbClr val="263B3F"/>
                 </a:solidFill>
@@ -16478,7 +16717,7 @@
               </a:defRPr>
             </a:pPr>
             <a:r>
-              <a:rPr sz="1350" b="0" i="0">
+              <a:rPr sz="2400" b="0" i="0" dirty="0">
                 <a:solidFill>
                   <a:srgbClr val="263B3F"/>
                 </a:solidFill>
@@ -16490,7 +16729,7 @@
             </a:r>
           </a:p>
           <a:p>
-            <a:endParaRPr sz="1350" b="0" i="0">
+            <a:endParaRPr sz="2400" b="0" i="0" dirty="0">
               <a:solidFill>
                 <a:srgbClr val="263B3F"/>
               </a:solidFill>
@@ -16511,7 +16750,7 @@
               </a:defRPr>
             </a:pPr>
             <a:r>
-              <a:rPr sz="1350" b="0" i="0">
+              <a:rPr sz="2400" b="0" i="0" dirty="0">
                 <a:solidFill>
                   <a:srgbClr val="263B3F"/>
                 </a:solidFill>
@@ -16706,7 +16945,7 @@
         </p:spPr>
         <p:txBody>
           <a:bodyPr anchor="ctr">
-            <a:normAutofit/>
+            <a:noAutofit/>
           </a:bodyPr>
           <a:lstStyle/>
           <a:p>
@@ -16721,7 +16960,7 @@
               </a:defRPr>
             </a:pPr>
             <a:r>
-              <a:rPr sz="1350" b="0" i="0">
+              <a:rPr sz="2000" b="0" i="0" dirty="0">
                 <a:solidFill>
                   <a:srgbClr val="263B3F"/>
                 </a:solidFill>
@@ -16733,7 +16972,7 @@
             </a:r>
           </a:p>
           <a:p>
-            <a:endParaRPr sz="1350" b="0" i="0">
+            <a:endParaRPr sz="2000" b="0" i="0" dirty="0">
               <a:solidFill>
                 <a:srgbClr val="263B3F"/>
               </a:solidFill>
@@ -16754,7 +16993,7 @@
               </a:defRPr>
             </a:pPr>
             <a:r>
-              <a:rPr sz="1350" b="0" i="0">
+              <a:rPr sz="2000" b="0" i="0" dirty="0">
                 <a:solidFill>
                   <a:srgbClr val="263B3F"/>
                 </a:solidFill>
@@ -17079,7 +17318,7 @@
         </p:spPr>
         <p:txBody>
           <a:bodyPr anchor="ctr">
-            <a:normAutofit/>
+            <a:noAutofit/>
           </a:bodyPr>
           <a:lstStyle/>
           <a:p>
@@ -17094,7 +17333,7 @@
               </a:defRPr>
             </a:pPr>
             <a:r>
-              <a:rPr sz="1725" b="0" i="0">
+              <a:rPr sz="2400" b="0" i="0" dirty="0">
                 <a:solidFill>
                   <a:srgbClr val="FFFFFF"/>
                 </a:solidFill>
@@ -17117,7 +17356,7 @@
               </a:defRPr>
             </a:pPr>
             <a:r>
-              <a:rPr sz="1725" b="0" i="0">
+              <a:rPr sz="2400" b="0" i="0" dirty="0">
                 <a:solidFill>
                   <a:srgbClr val="FFFFFF"/>
                 </a:solidFill>
@@ -17140,7 +17379,7 @@
               </a:defRPr>
             </a:pPr>
             <a:r>
-              <a:rPr sz="1725" b="0" i="0">
+              <a:rPr sz="2400" b="0" i="0" dirty="0">
                 <a:solidFill>
                   <a:srgbClr val="FFFFFF"/>
                 </a:solidFill>
@@ -17276,7 +17515,7 @@
         </p:spPr>
         <p:txBody>
           <a:bodyPr anchor="ctr">
-            <a:normAutofit/>
+            <a:noAutofit/>
           </a:bodyPr>
           <a:lstStyle/>
           <a:p>
@@ -17291,7 +17530,7 @@
               </a:defRPr>
             </a:pPr>
             <a:r>
-              <a:rPr sz="1725" b="0" i="0">
+              <a:rPr sz="2400" b="0" i="0" dirty="0">
                 <a:solidFill>
                   <a:srgbClr val="263B3F"/>
                 </a:solidFill>
@@ -17314,7 +17553,7 @@
               </a:defRPr>
             </a:pPr>
             <a:r>
-              <a:rPr sz="1725" b="0" i="0">
+              <a:rPr sz="2400" b="0" i="0" dirty="0">
                 <a:solidFill>
                   <a:srgbClr val="263B3F"/>
                 </a:solidFill>
@@ -17337,7 +17576,7 @@
               </a:defRPr>
             </a:pPr>
             <a:r>
-              <a:rPr sz="1725" b="0" i="0">
+              <a:rPr sz="2400" b="0" i="0" dirty="0">
                 <a:solidFill>
                   <a:srgbClr val="263B3F"/>
                 </a:solidFill>
@@ -17367,7 +17606,7 @@
         <p:spPr>
           <a:xfrm>
             <a:off x="762000" y="5238750"/>
-            <a:ext cx="10668000" cy="523875"/>
+            <a:ext cx="10668000" cy="1333500"/>
           </a:xfrm>
           <a:prstGeom prst="rect">
             <a:avLst/>
@@ -17394,16 +17633,57 @@
               </a:defRPr>
             </a:pPr>
             <a:r>
-              <a:rPr sz="1725" b="1" i="0">
-                <a:solidFill>
-                  <a:srgbClr val="263B3F"/>
-                </a:solidFill>
-                <a:latin typeface="Calibri"/>
-                <a:ea typeface="Calibri"/>
-                <a:cs typeface="Calibri"/>
-              </a:rPr>
-              <a:t>Strategic sidestepping asks whether small states can move beyond a single line between two great powers</a:t>
-            </a:r>
+              <a:rPr sz="2000" b="1" i="0" dirty="0">
+                <a:solidFill>
+                  <a:srgbClr val="263B3F"/>
+                </a:solidFill>
+                <a:latin typeface="Calibri"/>
+                <a:ea typeface="Calibri"/>
+                <a:cs typeface="Calibri"/>
+              </a:rPr>
+              <a:t>Strategic sidestepping</a:t>
+            </a:r>
+            <a:r>
+              <a:rPr lang="en-US" sz="2000" b="1" i="0" dirty="0">
+                <a:solidFill>
+                  <a:srgbClr val="263B3F"/>
+                </a:solidFill>
+                <a:latin typeface="Calibri"/>
+                <a:ea typeface="Calibri"/>
+                <a:cs typeface="Calibri"/>
+              </a:rPr>
+              <a:t>:  Can</a:t>
+            </a:r>
+            <a:r>
+              <a:rPr sz="2000" b="1" i="0" dirty="0">
+                <a:solidFill>
+                  <a:srgbClr val="263B3F"/>
+                </a:solidFill>
+                <a:latin typeface="Calibri"/>
+                <a:ea typeface="Calibri"/>
+                <a:cs typeface="Calibri"/>
+              </a:rPr>
+              <a:t> small states move beyond a single line between two great powers</a:t>
+            </a:r>
+            <a:r>
+              <a:rPr lang="en-US" sz="2000" b="1" i="0" dirty="0">
+                <a:solidFill>
+                  <a:srgbClr val="263B3F"/>
+                </a:solidFill>
+                <a:latin typeface="Calibri"/>
+                <a:ea typeface="Calibri"/>
+                <a:cs typeface="Calibri"/>
+              </a:rPr>
+              <a:t>?</a:t>
+            </a:r>
+            <a:endParaRPr sz="2000" b="1" i="0" dirty="0">
+              <a:solidFill>
+                <a:srgbClr val="263B3F"/>
+              </a:solidFill>
+              <a:latin typeface="Calibri"/>
+              <a:ea typeface="Calibri"/>
+              <a:cs typeface="Calibri"/>
+            </a:endParaRPr>
           </a:p>
         </p:txBody>
       </p:sp>
@@ -17682,7 +17962,7 @@
         </p:spPr>
         <p:txBody>
           <a:bodyPr anchor="ctr">
-            <a:normAutofit/>
+            <a:noAutofit/>
           </a:bodyPr>
           <a:lstStyle/>
           <a:p>
@@ -17697,7 +17977,7 @@
               </a:defRPr>
             </a:pPr>
             <a:r>
-              <a:rPr sz="1725" b="1" i="0">
+              <a:rPr sz="2000" b="1" i="0" dirty="0">
                 <a:solidFill>
                   <a:srgbClr val="263B3F"/>
                 </a:solidFill>
@@ -17720,7 +18000,7 @@
               </a:defRPr>
             </a:pPr>
             <a:r>
-              <a:rPr sz="1725" b="1" i="0">
+              <a:rPr sz="2000" b="1" i="0" dirty="0">
                 <a:solidFill>
                   <a:srgbClr val="263B3F"/>
                 </a:solidFill>
@@ -17743,7 +18023,7 @@
               </a:defRPr>
             </a:pPr>
             <a:r>
-              <a:rPr sz="1725" b="1" i="0">
+              <a:rPr sz="2000" b="1" i="0" dirty="0">
                 <a:solidFill>
                   <a:srgbClr val="263B3F"/>
                 </a:solidFill>
@@ -17766,7 +18046,7 @@
               </a:defRPr>
             </a:pPr>
             <a:r>
-              <a:rPr sz="1725" b="1" i="0">
+              <a:rPr sz="2000" b="1" i="0" dirty="0">
                 <a:solidFill>
                   <a:srgbClr val="263B3F"/>
                 </a:solidFill>
@@ -17937,7 +18217,7 @@
               </a:defRPr>
             </a:pPr>
             <a:r>
-              <a:rPr sz="1725" b="1" i="0">
+              <a:rPr sz="2000" b="1" i="0" dirty="0">
                 <a:solidFill>
                   <a:srgbClr val="263B3F"/>
                 </a:solidFill>
@@ -17960,7 +18240,7 @@
               </a:defRPr>
             </a:pPr>
             <a:r>
-              <a:rPr sz="1725" b="1" i="0">
+              <a:rPr sz="2000" b="1" i="0" dirty="0">
                 <a:solidFill>
                   <a:srgbClr val="263B3F"/>
                 </a:solidFill>
@@ -17983,7 +18263,7 @@
               </a:defRPr>
             </a:pPr>
             <a:r>
-              <a:rPr sz="1725" b="1" i="0">
+              <a:rPr sz="2000" b="1" i="0" dirty="0">
                 <a:solidFill>
                   <a:srgbClr val="263B3F"/>
                 </a:solidFill>
@@ -18006,7 +18286,7 @@
               </a:defRPr>
             </a:pPr>
             <a:r>
-              <a:rPr sz="1725" b="1" i="0">
+              <a:rPr sz="2000" b="1" i="0" dirty="0">
                 <a:solidFill>
                   <a:srgbClr val="263B3F"/>
                 </a:solidFill>
@@ -18035,7 +18315,7 @@
         </p:nvSpPr>
         <p:spPr>
           <a:xfrm>
-            <a:off x="762000" y="4953000"/>
+            <a:off x="762000" y="5282611"/>
             <a:ext cx="10668000" cy="762000"/>
           </a:xfrm>
           <a:prstGeom prst="rect">
@@ -18072,7 +18352,7 @@
         </p:nvSpPr>
         <p:spPr>
           <a:xfrm>
-            <a:off x="1047750" y="5095875"/>
+            <a:off x="1047750" y="5393589"/>
             <a:ext cx="10096500" cy="476250"/>
           </a:xfrm>
           <a:prstGeom prst="rect">
@@ -18100,7 +18380,7 @@
               </a:defRPr>
             </a:pPr>
             <a:r>
-              <a:rPr sz="1800" b="1" i="0">
+              <a:rPr sz="1800" b="1" i="0" dirty="0">
                 <a:solidFill>
                   <a:srgbClr val="FFFFFF"/>
                 </a:solidFill>
@@ -18499,7 +18779,7 @@
               </a:defRPr>
             </a:pPr>
             <a:r>
-              <a:rPr sz="1350" b="0" i="0">
+              <a:rPr sz="2400" b="0" i="0" dirty="0">
                 <a:solidFill>
                   <a:srgbClr val="263B3F"/>
                 </a:solidFill>
@@ -18709,7 +18989,7 @@
               </a:defRPr>
             </a:pPr>
             <a:r>
-              <a:rPr sz="1350" b="0" i="0">
+              <a:rPr sz="2400" b="0" i="0" dirty="0">
                 <a:solidFill>
                   <a:srgbClr val="263B3F"/>
                 </a:solidFill>
@@ -18919,7 +19199,7 @@
               </a:defRPr>
             </a:pPr>
             <a:r>
-              <a:rPr sz="1350" b="0" i="0">
+              <a:rPr sz="2400" b="0" i="0" dirty="0">
                 <a:solidFill>
                   <a:srgbClr val="263B3F"/>
                 </a:solidFill>
@@ -18976,7 +19256,7 @@
               </a:defRPr>
             </a:pPr>
             <a:r>
-              <a:rPr sz="1950" b="1" i="0">
+              <a:rPr sz="2400" b="1" i="0" dirty="0">
                 <a:solidFill>
                   <a:srgbClr val="F28C18"/>
                 </a:solidFill>
@@ -20376,7 +20656,7 @@
               </a:defRPr>
             </a:pPr>
             <a:r>
-              <a:rPr sz="1500" b="1" i="0">
+              <a:rPr sz="1500" b="1" i="0" dirty="0">
                 <a:solidFill>
                   <a:srgbClr val="263B3F"/>
                 </a:solidFill>
@@ -20405,7 +20685,7 @@
         </p:nvSpPr>
         <p:spPr>
           <a:xfrm>
-            <a:off x="762000" y="5572125"/>
+            <a:off x="762000" y="5954899"/>
             <a:ext cx="10668000" cy="381000"/>
           </a:xfrm>
           <a:prstGeom prst="rect">
@@ -20888,7 +21168,7 @@
               </a:defRPr>
             </a:pPr>
             <a:r>
-              <a:rPr sz="1200" b="0" i="1">
+              <a:rPr sz="1200" b="0" i="1" dirty="0">
                 <a:solidFill>
                   <a:srgbClr val="657275"/>
                 </a:solidFill>
@@ -20896,7 +21176,29 @@
                 <a:ea typeface="Calibri"/>
                 <a:cs typeface="Calibri"/>
               </a:rPr>
-              <a:t>Despite 1997, 2003, 2008 and 2020, the region transformed</a:t>
+              <a:t>Despite 1997, 2003, 2008</a:t>
+            </a:r>
+            <a:r>
+              <a:rPr lang="en-US" sz="1200" b="0" i="1" dirty="0">
+                <a:solidFill>
+                  <a:srgbClr val="657275"/>
+                </a:solidFill>
+                <a:latin typeface="Calibri"/>
+                <a:ea typeface="Calibri"/>
+                <a:cs typeface="Calibri"/>
+              </a:rPr>
+              <a:t>,</a:t>
+            </a:r>
+            <a:r>
+              <a:rPr sz="1200" b="0" i="1" dirty="0">
+                <a:solidFill>
+                  <a:srgbClr val="657275"/>
+                </a:solidFill>
+                <a:latin typeface="Calibri"/>
+                <a:ea typeface="Calibri"/>
+                <a:cs typeface="Calibri"/>
+              </a:rPr>
+              <a:t> and 2020, the region transformed</a:t>
             </a:r>
           </a:p>
         </p:txBody>
@@ -22442,7 +22744,7 @@
               </a:defRPr>
             </a:pPr>
             <a:r>
-              <a:rPr sz="1200" b="0" i="1">
+              <a:rPr sz="1200" b="0" i="1" dirty="0">
                 <a:solidFill>
                   <a:srgbClr val="657275"/>
                 </a:solidFill>
@@ -22450,7 +22752,29 @@
                 <a:ea typeface="Calibri"/>
                 <a:cs typeface="Calibri"/>
               </a:rPr>
-              <a:t>The growth model now meets ageing, employment gaps and sharply different national trajectories</a:t>
+              <a:t>The growth model now meets ageing, employment gaps</a:t>
+            </a:r>
+            <a:r>
+              <a:rPr lang="en-US" sz="1200" b="0" i="1" dirty="0">
+                <a:solidFill>
+                  <a:srgbClr val="657275"/>
+                </a:solidFill>
+                <a:latin typeface="Calibri"/>
+                <a:ea typeface="Calibri"/>
+                <a:cs typeface="Calibri"/>
+              </a:rPr>
+              <a:t>,</a:t>
+            </a:r>
+            <a:r>
+              <a:rPr sz="1200" b="0" i="1" dirty="0">
+                <a:solidFill>
+                  <a:srgbClr val="657275"/>
+                </a:solidFill>
+                <a:latin typeface="Calibri"/>
+                <a:ea typeface="Calibri"/>
+                <a:cs typeface="Calibri"/>
+              </a:rPr>
+              <a:t> and sharply different national trajectories</a:t>
             </a:r>
           </a:p>
         </p:txBody>
@@ -22689,15 +23013,37 @@
               </a:defRPr>
             </a:pPr>
             <a:r>
-              <a:rPr sz="1350" b="0" i="0">
-                <a:solidFill>
-                  <a:srgbClr val="263B3F"/>
-                </a:solidFill>
-                <a:latin typeface="Calibri"/>
-                <a:ea typeface="Calibri"/>
-                <a:cs typeface="Calibri"/>
-              </a:rPr>
-              <a:t>By 2025, 21% of Singapore and 20% of Korea are aged 65 or older. Japan stands at 28%.</a:t>
+              <a:rPr sz="2400" b="0" i="0" dirty="0">
+                <a:solidFill>
+                  <a:srgbClr val="263B3F"/>
+                </a:solidFill>
+                <a:latin typeface="Calibri"/>
+                <a:ea typeface="Calibri"/>
+                <a:cs typeface="Calibri"/>
+              </a:rPr>
+              <a:t>By 2025, 21% of Singapore and 20% of </a:t>
+            </a:r>
+            <a:r>
+              <a:rPr lang="en-US" sz="2400" b="0" i="0" dirty="0">
+                <a:solidFill>
+                  <a:srgbClr val="263B3F"/>
+                </a:solidFill>
+                <a:latin typeface="Calibri"/>
+                <a:ea typeface="Calibri"/>
+                <a:cs typeface="Calibri"/>
+              </a:rPr>
+              <a:t>South </a:t>
+            </a:r>
+            <a:r>
+              <a:rPr sz="2400" b="0" i="0" dirty="0">
+                <a:solidFill>
+                  <a:srgbClr val="263B3F"/>
+                </a:solidFill>
+                <a:latin typeface="Calibri"/>
+                <a:ea typeface="Calibri"/>
+                <a:cs typeface="Calibri"/>
+              </a:rPr>
+              <a:t>Korea are aged 65 or older. Japan stands at 28%.</a:t>
             </a:r>
           </a:p>
         </p:txBody>
@@ -22899,7 +23245,7 @@
               </a:defRPr>
             </a:pPr>
             <a:r>
-              <a:rPr sz="1350" b="0" i="0">
+              <a:rPr sz="2400" b="0" i="0" dirty="0">
                 <a:solidFill>
                   <a:srgbClr val="263B3F"/>
                 </a:solidFill>
@@ -23109,15 +23455,59 @@
               </a:defRPr>
             </a:pPr>
             <a:r>
-              <a:rPr sz="1350" b="0" i="0">
-                <a:solidFill>
-                  <a:srgbClr val="263B3F"/>
-                </a:solidFill>
-                <a:latin typeface="Calibri"/>
-                <a:ea typeface="Calibri"/>
-                <a:cs typeface="Calibri"/>
-              </a:rPr>
-              <a:t>A steady-state calculation implies a 17% fall in GDP per capita even under favourable reallocation assumptions.</a:t>
+              <a:rPr sz="2400" b="0" i="0" dirty="0">
+                <a:solidFill>
+                  <a:srgbClr val="263B3F"/>
+                </a:solidFill>
+                <a:latin typeface="Calibri"/>
+                <a:ea typeface="Calibri"/>
+                <a:cs typeface="Calibri"/>
+              </a:rPr>
+              <a:t>A steady-state calculation implies a 7</a:t>
+            </a:r>
+            <a:r>
+              <a:rPr lang="en-US" sz="2400" b="0" i="0" dirty="0">
+                <a:solidFill>
+                  <a:srgbClr val="263B3F"/>
+                </a:solidFill>
+                <a:latin typeface="Calibri"/>
+                <a:ea typeface="Calibri"/>
+                <a:cs typeface="Calibri"/>
+              </a:rPr>
+              <a:t>.5</a:t>
+            </a:r>
+            <a:r>
+              <a:rPr sz="2400" b="0" i="0" dirty="0">
+                <a:solidFill>
+                  <a:srgbClr val="263B3F"/>
+                </a:solidFill>
+                <a:latin typeface="Calibri"/>
+                <a:ea typeface="Calibri"/>
+                <a:cs typeface="Calibri"/>
+              </a:rPr>
+              <a:t>% fall in GDP per capita even under </a:t>
+            </a:r>
+            <a:r>
+              <a:rPr sz="2400" b="0" i="0" dirty="0" err="1">
+                <a:solidFill>
+                  <a:srgbClr val="263B3F"/>
+                </a:solidFill>
+                <a:latin typeface="Calibri"/>
+                <a:ea typeface="Calibri"/>
+                <a:cs typeface="Calibri"/>
+              </a:rPr>
+              <a:t>favourable</a:t>
+            </a:r>
+            <a:r>
+              <a:rPr sz="2400" b="0" i="0" dirty="0">
+                <a:solidFill>
+                  <a:srgbClr val="263B3F"/>
+                </a:solidFill>
+                <a:latin typeface="Calibri"/>
+                <a:ea typeface="Calibri"/>
+                <a:cs typeface="Calibri"/>
+              </a:rPr>
+              <a:t> reallocation assumptions.</a:t>
             </a:r>
           </a:p>
         </p:txBody>
@@ -23441,8 +23831,8 @@
         </p:nvSpPr>
         <p:spPr>
           <a:xfrm>
-            <a:off x="857250" y="2667000"/>
-            <a:ext cx="2667000" cy="666750"/>
+            <a:off x="857250" y="2666999"/>
+            <a:ext cx="2667000" cy="1000125"/>
           </a:xfrm>
           <a:prstGeom prst="rect">
             <a:avLst/>
@@ -23469,7 +23859,7 @@
               </a:defRPr>
             </a:pPr>
             <a:r>
-              <a:rPr sz="1425" b="0" i="0">
+              <a:rPr sz="2400" b="0" i="0" dirty="0">
                 <a:solidFill>
                   <a:srgbClr val="657275"/>
                 </a:solidFill>
@@ -23556,7 +23946,7 @@
         <p:spPr>
           <a:xfrm>
             <a:off x="4762500" y="2667000"/>
-            <a:ext cx="2667000" cy="666750"/>
+            <a:ext cx="2667000" cy="1000124"/>
           </a:xfrm>
           <a:prstGeom prst="rect">
             <a:avLst/>
@@ -23568,7 +23958,7 @@
         </p:spPr>
         <p:txBody>
           <a:bodyPr anchor="ctr">
-            <a:normAutofit/>
+            <a:noAutofit/>
           </a:bodyPr>
           <a:lstStyle/>
           <a:p>
@@ -23583,7 +23973,7 @@
               </a:defRPr>
             </a:pPr>
             <a:r>
-              <a:rPr sz="1425" b="0" i="0">
+              <a:rPr sz="2400" b="0" i="0" dirty="0">
                 <a:solidFill>
                   <a:srgbClr val="657275"/>
                 </a:solidFill>
@@ -23670,7 +24060,7 @@
         <p:spPr>
           <a:xfrm>
             <a:off x="8667750" y="2667000"/>
-            <a:ext cx="2667000" cy="762000"/>
+            <a:ext cx="2667000" cy="1000124"/>
           </a:xfrm>
           <a:prstGeom prst="rect">
             <a:avLst/>
@@ -23682,7 +24072,7 @@
         </p:spPr>
         <p:txBody>
           <a:bodyPr anchor="ctr">
-            <a:normAutofit/>
+            <a:noAutofit/>
           </a:bodyPr>
           <a:lstStyle/>
           <a:p>
@@ -23697,7 +24087,7 @@
               </a:defRPr>
             </a:pPr>
             <a:r>
-              <a:rPr sz="1425" b="0" i="0">
+              <a:rPr lang="en-US" sz="2000" b="0" i="0" dirty="0">
                 <a:solidFill>
                   <a:srgbClr val="657275"/>
                 </a:solidFill>
@@ -23705,7 +24095,29 @@
                 <a:ea typeface="Calibri"/>
                 <a:cs typeface="Calibri"/>
               </a:rPr>
-              <a:t>Richest economies outside the US average only 4m people</a:t>
+              <a:t>World’s </a:t>
+            </a:r>
+            <a:r>
+              <a:rPr lang="en-US" sz="2000" dirty="0">
+                <a:solidFill>
+                  <a:srgbClr val="657275"/>
+                </a:solidFill>
+                <a:latin typeface="Calibri"/>
+                <a:ea typeface="Calibri"/>
+                <a:cs typeface="Calibri"/>
+              </a:rPr>
+              <a:t>r</a:t>
+            </a:r>
+            <a:r>
+              <a:rPr sz="2000" b="0" i="0" dirty="0">
+                <a:solidFill>
+                  <a:srgbClr val="657275"/>
+                </a:solidFill>
+                <a:latin typeface="Calibri"/>
+                <a:ea typeface="Calibri"/>
+                <a:cs typeface="Calibri"/>
+              </a:rPr>
+              <a:t>ichest economies outside US average only 4m people</a:t>
             </a:r>
           </a:p>
         </p:txBody>
@@ -23726,7 +24138,7 @@
         </p:nvSpPr>
         <p:spPr>
           <a:xfrm>
-            <a:off x="857250" y="3905250"/>
+            <a:off x="857250" y="4160436"/>
             <a:ext cx="10477500" cy="1143000"/>
           </a:xfrm>
           <a:prstGeom prst="rect">
@@ -23763,7 +24175,7 @@
         </p:nvSpPr>
         <p:spPr>
           <a:xfrm>
-            <a:off x="1238250" y="4095750"/>
+            <a:off x="1238250" y="4372208"/>
             <a:ext cx="9715500" cy="714375"/>
           </a:xfrm>
           <a:prstGeom prst="rect">
@@ -23791,7 +24203,7 @@
               </a:defRPr>
             </a:pPr>
             <a:r>
-              <a:rPr sz="2025" b="1" i="0">
+              <a:rPr sz="2025" b="1" i="0" dirty="0">
                 <a:solidFill>
                   <a:srgbClr val="FFFFFF"/>
                 </a:solidFill>
@@ -23943,7 +24355,7 @@
               </a:defRPr>
             </a:pPr>
             <a:r>
-              <a:rPr sz="2925" b="1" i="0">
+              <a:rPr sz="2925" b="1" i="0" dirty="0">
                 <a:solidFill>
                   <a:srgbClr val="FFFFFF"/>
                 </a:solidFill>
@@ -23951,7 +24363,29 @@
                 <a:ea typeface="Calibri"/>
                 <a:cs typeface="Calibri"/>
               </a:rPr>
-              <a:t>“The strong do what they can; the weak suffer what they must.”</a:t>
+              <a:t>“The strong do what they </a:t>
+            </a:r>
+            <a:r>
+              <a:rPr lang="en-US" sz="2925" b="1" i="0" dirty="0">
+                <a:solidFill>
+                  <a:srgbClr val="FFFFFF"/>
+                </a:solidFill>
+                <a:latin typeface="Calibri"/>
+                <a:ea typeface="Calibri"/>
+                <a:cs typeface="Calibri"/>
+              </a:rPr>
+              <a:t>will</a:t>
+            </a:r>
+            <a:r>
+              <a:rPr sz="2925" b="1" i="0" dirty="0">
+                <a:solidFill>
+                  <a:srgbClr val="FFFFFF"/>
+                </a:solidFill>
+                <a:latin typeface="Calibri"/>
+                <a:ea typeface="Calibri"/>
+                <a:cs typeface="Calibri"/>
+              </a:rPr>
+              <a:t>; the weak suffer what they must.”</a:t>
             </a:r>
           </a:p>
         </p:txBody>
@@ -24009,7 +24443,7 @@
         </p:nvSpPr>
         <p:spPr>
           <a:xfrm>
-            <a:off x="523875" y="3857625"/>
+            <a:off x="449447" y="4200524"/>
             <a:ext cx="10287000" cy="476250"/>
           </a:xfrm>
           <a:prstGeom prst="rect">
@@ -24037,7 +24471,7 @@
               </a:defRPr>
             </a:pPr>
             <a:r>
-              <a:rPr sz="1275" b="0" i="1">
+              <a:rPr sz="1275" b="0" i="1" dirty="0">
                 <a:solidFill>
                   <a:srgbClr val="CCD6D5"/>
                 </a:solidFill>
@@ -24066,7 +24500,7 @@
         </p:nvSpPr>
         <p:spPr>
           <a:xfrm>
-            <a:off x="523875" y="4619625"/>
+            <a:off x="449447" y="3795712"/>
             <a:ext cx="5715000" cy="285750"/>
           </a:xfrm>
           <a:prstGeom prst="rect">
@@ -24094,7 +24528,7 @@
               </a:defRPr>
             </a:pPr>
             <a:r>
-              <a:rPr sz="1125" b="0" i="1">
+              <a:rPr sz="1125" b="0" i="1" dirty="0">
                 <a:solidFill>
                   <a:srgbClr val="CCD6D5"/>
                 </a:solidFill>
@@ -24435,7 +24869,7 @@
               </a:defRPr>
             </a:pPr>
             <a:r>
-              <a:rPr sz="2325" b="1" i="0">
+              <a:rPr sz="2800" b="1" i="0" dirty="0">
                 <a:solidFill>
                   <a:srgbClr val="263B3F"/>
                 </a:solidFill>
@@ -24739,7 +25173,7 @@
               </a:defRPr>
             </a:pPr>
             <a:r>
-              <a:rPr sz="1350" b="0" i="0">
+              <a:rPr sz="2400" b="0" i="0" dirty="0">
                 <a:solidFill>
                   <a:srgbClr val="263B3F"/>
                 </a:solidFill>
@@ -24949,7 +25383,7 @@
               </a:defRPr>
             </a:pPr>
             <a:r>
-              <a:rPr sz="1350" b="0" i="0">
+              <a:rPr sz="2400" b="0" i="0" dirty="0">
                 <a:solidFill>
                   <a:srgbClr val="263B3F"/>
                 </a:solidFill>
@@ -25159,7 +25593,7 @@
               </a:defRPr>
             </a:pPr>
             <a:r>
-              <a:rPr sz="1350" b="0" i="0">
+              <a:rPr sz="2400" b="0" i="0" dirty="0">
                 <a:solidFill>
                   <a:srgbClr val="263B3F"/>
                 </a:solidFill>
@@ -25189,7 +25623,7 @@
         <p:spPr>
           <a:xfrm>
             <a:off x="495300" y="5286375"/>
-            <a:ext cx="11201400" cy="523875"/>
+            <a:ext cx="11201400" cy="1103792"/>
           </a:xfrm>
           <a:prstGeom prst="rect">
             <a:avLst/>
@@ -25216,7 +25650,7 @@
               </a:defRPr>
             </a:pPr>
             <a:r>
-              <a:rPr sz="1800" b="1" i="0">
+              <a:rPr sz="2400" b="1" i="0" dirty="0">
                 <a:solidFill>
                   <a:srgbClr val="F28C18"/>
                 </a:solidFill>
@@ -25224,7 +25658,29 @@
                 <a:ea typeface="Calibri"/>
                 <a:cs typeface="Calibri"/>
               </a:rPr>
-              <a:t>Power still mattered. Rules changed how directly power translated into outcomes.</a:t>
+              <a:t>Power still mattered. Rules change how directly power translate</a:t>
+            </a:r>
+            <a:r>
+              <a:rPr lang="en-US" sz="2400" b="1" dirty="0">
+                <a:solidFill>
+                  <a:srgbClr val="F28C18"/>
+                </a:solidFill>
+                <a:latin typeface="Calibri"/>
+                <a:ea typeface="Calibri"/>
+                <a:cs typeface="Calibri"/>
+              </a:rPr>
+              <a:t>s</a:t>
+            </a:r>
+            <a:r>
+              <a:rPr sz="2400" b="1" i="0" dirty="0">
+                <a:solidFill>
+                  <a:srgbClr val="F28C18"/>
+                </a:solidFill>
+                <a:latin typeface="Calibri"/>
+                <a:ea typeface="Calibri"/>
+                <a:cs typeface="Calibri"/>
+              </a:rPr>
+              <a:t> into outcomes.</a:t>
             </a:r>
           </a:p>
         </p:txBody>

</xml_diff>